<commit_message>
docs: separate core solution from optional simulator add-ins
</commit_message>
<xml_diff>
--- a/docs/architecture/generic-sidebar-reference-architecture.pptx
+++ b/docs/architecture/generic-sidebar-reference-architecture.pptx
@@ -505,7 +505,7 @@
               <a:t>
 This slide presents the reusable Generic Sidebar architecture.
 The required runtime path moves from a model-driven form through Generic_OpenSidebar and Xrm.App.sidePanes into the shared runtime. The runtime reads the default sidebar_genericsidebar row and active linked-agent rows, applies routing policy, and renders the configured experience.
-Orange dashed lines represent runtime configuration reads. Purple dashed lines represent optional adapters, including Entra ID, Copilot Studio, web or phone sidecars, Azure Functions, and Azure Communication Services.
+Orange dashed lines represent Core runtime configuration reads. Purple dashed lines represent separately deployed optional adapters and add-ins, including Entra ID, Copilot Studio, Android Phone, Genesys Softphone, Azure Functions, and Azure Communication Services. Android, Genesys, GenericSoftphone, and gensoft_* components are not members or dependencies of the base Core solution package.
 The reuse contract is to keep the launcher and runtime stable while changing experiences through governed Dataverse configuration and narrowly scoped adapters.
 </a:t>
             </a:r>
@@ -997,7 +997,7 @@
                 <a:ea typeface="Segoe UI" pitchFamily="34" charset="-122"/>
                 <a:cs typeface="Segoe UI" pitchFamily="34" charset="-120"/>
               </a:rPr>
-              <a:t>Configuration-driven side panes for Dynamics 365 and model-driven apps</a:t>
+              <a:t>Independent Core solution with separately deployed optional add-ins</a:t>
             </a:r>
             <a:endParaRPr lang="en-US" sz="1050" dirty="0"/>
           </a:p>
@@ -1316,7 +1316,7 @@
                 <a:ea typeface="Segoe UI" pitchFamily="34" charset="-122"/>
                 <a:cs typeface="Segoe UI" pitchFamily="34" charset="-120"/>
               </a:rPr>
-              <a:t>3  ADMINISTRATION AND DATA</a:t>
+              <a:t>3  CORE ADMINISTRATION AND DATA</a:t>
             </a:r>
             <a:endParaRPr lang="en-US" sz="1220" dirty="0"/>
           </a:p>
@@ -1386,7 +1386,7 @@
                 <a:ea typeface="Segoe UI" pitchFamily="34" charset="-122"/>
                 <a:cs typeface="Segoe UI" pitchFamily="34" charset="-120"/>
               </a:rPr>
-              <a:t>4  OPTIONAL EXPERIENCE ADAPTERS</a:t>
+              <a:t>4  OPTIONAL ADD-INS / ADAPTERS</a:t>
             </a:r>
             <a:endParaRPr lang="en-US" sz="1220" dirty="0"/>
           </a:p>
@@ -2943,17 +2943,17 @@
               <a:buNone/>
             </a:pPr>
             <a:r>
-              <a:rPr lang="en-US" sz="800" b="1" dirty="0">
-                <a:solidFill>
-                  <a:srgbClr val="1E1E1E"/>
-                </a:solidFill>
-                <a:latin typeface="Segoe UI" pitchFamily="34" charset="0"/>
-                <a:ea typeface="Segoe UI" pitchFamily="34" charset="-122"/>
-                <a:cs typeface="Segoe UI" pitchFamily="34" charset="-120"/>
-              </a:rPr>
-              <a:t>Web / phone sidecars</a:t>
-            </a:r>
-            <a:endParaRPr lang="en-US" sz="800" dirty="0"/>
+              <a:rPr lang="en-US" sz="740" b="1" dirty="0">
+                <a:solidFill>
+                  <a:srgbClr val="1E1E1E"/>
+                </a:solidFill>
+                <a:latin typeface="Segoe UI" pitchFamily="34" charset="0"/>
+                <a:ea typeface="Segoe UI" pitchFamily="34" charset="-122"/>
+                <a:cs typeface="Segoe UI" pitchFamily="34" charset="-120"/>
+              </a:rPr>
+              <a:t>Android / Genesys add-ins</a:t>
+            </a:r>
+            <a:endParaRPr lang="en-US" sz="740" dirty="0"/>
           </a:p>
         </p:txBody>
       </p:sp>

</xml_diff>